<commit_message>
Add two-layer scope guardrails
- Agent prompt now refuses off-topic questions (weather, news, etc.)
  without calling any tool
- UI suppresses chart rendering when the agent's answer matches a
  refusal pattern, so visuals never contradict a 'cannot answer' reply
- README documents the two-layer guardrail design
- Slide 7 adds a 'Two-layer scope guardrails' card
</commit_message>
<xml_diff>
--- a/WorldCupGenAI_Slides.pptx
+++ b/WorldCupGenAI_Slides.pptx
@@ -8353,8 +8353,8 @@
         </p:nvSpPr>
         <p:spPr>
           <a:xfrm>
-            <a:off x="548640" y="1188720"/>
-            <a:ext cx="228600" cy="822960"/>
+            <a:off x="548640" y="1097280"/>
+            <a:ext cx="228600" cy="731520"/>
           </a:xfrm>
           <a:prstGeom prst="rect">
             <a:avLst/>
@@ -8396,7 +8396,7 @@
         </p:nvSpPr>
         <p:spPr>
           <a:xfrm>
-            <a:off x="914400" y="1188720"/>
+            <a:off x="914400" y="1097280"/>
             <a:ext cx="10698480" cy="365760"/>
           </a:xfrm>
           <a:prstGeom prst="rect">
@@ -8412,7 +8412,7 @@
           <a:p>
             <a:pPr algn="l"/>
             <a:r>
-              <a:rPr sz="1700" b="1">
+              <a:rPr sz="1500" b="1">
                 <a:solidFill>
                   <a:srgbClr val="1E4B8F"/>
                 </a:solidFill>
@@ -8431,8 +8431,8 @@
         </p:nvSpPr>
         <p:spPr>
           <a:xfrm>
-            <a:off x="914400" y="1554480"/>
-            <a:ext cx="10698480" cy="548640"/>
+            <a:off x="914400" y="1444752"/>
+            <a:ext cx="10698480" cy="502920"/>
           </a:xfrm>
           <a:prstGeom prst="rect">
             <a:avLst/>
@@ -8447,7 +8447,7 @@
           <a:p>
             <a:pPr algn="l"/>
             <a:r>
-              <a:rPr sz="1300" b="0">
+              <a:rPr sz="1200" b="0">
                 <a:solidFill>
                   <a:srgbClr val="222222"/>
                 </a:solidFill>
@@ -8466,8 +8466,8 @@
         </p:nvSpPr>
         <p:spPr>
           <a:xfrm>
-            <a:off x="548640" y="2194560"/>
-            <a:ext cx="228600" cy="822960"/>
+            <a:off x="548640" y="1965960"/>
+            <a:ext cx="228600" cy="731520"/>
           </a:xfrm>
           <a:prstGeom prst="rect">
             <a:avLst/>
@@ -8509,7 +8509,7 @@
         </p:nvSpPr>
         <p:spPr>
           <a:xfrm>
-            <a:off x="914400" y="2194560"/>
+            <a:off x="914400" y="1965960"/>
             <a:ext cx="10698480" cy="365760"/>
           </a:xfrm>
           <a:prstGeom prst="rect">
@@ -8525,7 +8525,7 @@
           <a:p>
             <a:pPr algn="l"/>
             <a:r>
-              <a:rPr sz="1700" b="1">
+              <a:rPr sz="1500" b="1">
                 <a:solidFill>
                   <a:srgbClr val="1E4B8F"/>
                 </a:solidFill>
@@ -8544,8 +8544,8 @@
         </p:nvSpPr>
         <p:spPr>
           <a:xfrm>
-            <a:off x="914400" y="2560320"/>
-            <a:ext cx="10698480" cy="548640"/>
+            <a:off x="914400" y="2313432"/>
+            <a:ext cx="10698480" cy="502920"/>
           </a:xfrm>
           <a:prstGeom prst="rect">
             <a:avLst/>
@@ -8560,7 +8560,7 @@
           <a:p>
             <a:pPr algn="l"/>
             <a:r>
-              <a:rPr sz="1300" b="0">
+              <a:rPr sz="1200" b="0">
                 <a:solidFill>
                   <a:srgbClr val="222222"/>
                 </a:solidFill>
@@ -8579,8 +8579,8 @@
         </p:nvSpPr>
         <p:spPr>
           <a:xfrm>
-            <a:off x="548640" y="3200400"/>
-            <a:ext cx="228600" cy="822960"/>
+            <a:off x="548640" y="2834639"/>
+            <a:ext cx="228600" cy="731520"/>
           </a:xfrm>
           <a:prstGeom prst="rect">
             <a:avLst/>
@@ -8622,7 +8622,7 @@
         </p:nvSpPr>
         <p:spPr>
           <a:xfrm>
-            <a:off x="914400" y="3200400"/>
+            <a:off x="914400" y="2834639"/>
             <a:ext cx="10698480" cy="365760"/>
           </a:xfrm>
           <a:prstGeom prst="rect">
@@ -8638,7 +8638,7 @@
           <a:p>
             <a:pPr algn="l"/>
             <a:r>
-              <a:rPr sz="1700" b="1">
+              <a:rPr sz="1500" b="1">
                 <a:solidFill>
                   <a:srgbClr val="1E4B8F"/>
                 </a:solidFill>
@@ -8657,8 +8657,8 @@
         </p:nvSpPr>
         <p:spPr>
           <a:xfrm>
-            <a:off x="914400" y="3566160"/>
-            <a:ext cx="10698480" cy="548640"/>
+            <a:off x="914400" y="3182111"/>
+            <a:ext cx="10698480" cy="502920"/>
           </a:xfrm>
           <a:prstGeom prst="rect">
             <a:avLst/>
@@ -8673,7 +8673,7 @@
           <a:p>
             <a:pPr algn="l"/>
             <a:r>
-              <a:rPr sz="1300" b="0">
+              <a:rPr sz="1200" b="0">
                 <a:solidFill>
                   <a:srgbClr val="222222"/>
                 </a:solidFill>
@@ -8692,8 +8692,8 @@
         </p:nvSpPr>
         <p:spPr>
           <a:xfrm>
-            <a:off x="548640" y="4206240"/>
-            <a:ext cx="228600" cy="822960"/>
+            <a:off x="548640" y="3703320"/>
+            <a:ext cx="228600" cy="731520"/>
           </a:xfrm>
           <a:prstGeom prst="rect">
             <a:avLst/>
@@ -8735,7 +8735,7 @@
         </p:nvSpPr>
         <p:spPr>
           <a:xfrm>
-            <a:off x="914400" y="4206240"/>
+            <a:off x="914400" y="3703320"/>
             <a:ext cx="10698480" cy="365760"/>
           </a:xfrm>
           <a:prstGeom prst="rect">
@@ -8751,7 +8751,7 @@
           <a:p>
             <a:pPr algn="l"/>
             <a:r>
-              <a:rPr sz="1700" b="1">
+              <a:rPr sz="1500" b="1">
                 <a:solidFill>
                   <a:srgbClr val="1E4B8F"/>
                 </a:solidFill>
@@ -8770,8 +8770,8 @@
         </p:nvSpPr>
         <p:spPr>
           <a:xfrm>
-            <a:off x="914400" y="4572000"/>
-            <a:ext cx="10698480" cy="548640"/>
+            <a:off x="914400" y="4050792"/>
+            <a:ext cx="10698480" cy="502920"/>
           </a:xfrm>
           <a:prstGeom prst="rect">
             <a:avLst/>
@@ -8786,7 +8786,7 @@
           <a:p>
             <a:pPr algn="l"/>
             <a:r>
-              <a:rPr sz="1300" b="0">
+              <a:rPr sz="1200" b="0">
                 <a:solidFill>
                   <a:srgbClr val="222222"/>
                 </a:solidFill>
@@ -8805,8 +8805,8 @@
         </p:nvSpPr>
         <p:spPr>
           <a:xfrm>
-            <a:off x="548640" y="5212080"/>
-            <a:ext cx="228600" cy="822960"/>
+            <a:off x="548640" y="4572000"/>
+            <a:ext cx="228600" cy="731520"/>
           </a:xfrm>
           <a:prstGeom prst="rect">
             <a:avLst/>
@@ -8848,7 +8848,7 @@
         </p:nvSpPr>
         <p:spPr>
           <a:xfrm>
-            <a:off x="914400" y="5212080"/>
+            <a:off x="914400" y="4572000"/>
             <a:ext cx="10698480" cy="365760"/>
           </a:xfrm>
           <a:prstGeom prst="rect">
@@ -8864,7 +8864,7 @@
           <a:p>
             <a:pPr algn="l"/>
             <a:r>
-              <a:rPr sz="1700" b="1">
+              <a:rPr sz="1500" b="1">
                 <a:solidFill>
                   <a:srgbClr val="1E4B8F"/>
                 </a:solidFill>
@@ -8883,8 +8883,8 @@
         </p:nvSpPr>
         <p:spPr>
           <a:xfrm>
-            <a:off x="914400" y="5577840"/>
-            <a:ext cx="10698480" cy="548640"/>
+            <a:off x="914400" y="4919472"/>
+            <a:ext cx="10698480" cy="502920"/>
           </a:xfrm>
           <a:prstGeom prst="rect">
             <a:avLst/>
@@ -8899,13 +8899,126 @@
           <a:p>
             <a:pPr algn="l"/>
             <a:r>
-              <a:rPr sz="1300" b="0">
+              <a:rPr sz="1200" b="0">
                 <a:solidFill>
                   <a:srgbClr val="222222"/>
                 </a:solidFill>
                 <a:latin typeface="Calibri"/>
               </a:rPr>
               <a:t>Onboarding for new users, ready made demo prompts for judges.</a:t>
+            </a:r>
+          </a:p>
+        </p:txBody>
+      </p:sp>
+      <p:sp>
+        <p:nvSpPr>
+          <p:cNvPr id="20" name="Rectangle 19"/>
+          <p:cNvSpPr/>
+          <p:nvPr/>
+        </p:nvSpPr>
+        <p:spPr>
+          <a:xfrm>
+            <a:off x="548640" y="5440680"/>
+            <a:ext cx="228600" cy="731520"/>
+          </a:xfrm>
+          <a:prstGeom prst="rect">
+            <a:avLst/>
+          </a:prstGeom>
+          <a:solidFill>
+            <a:srgbClr val="E53935"/>
+          </a:solidFill>
+          <a:ln>
+            <a:noFill/>
+          </a:ln>
+        </p:spPr>
+        <p:style>
+          <a:lnRef idx="1">
+            <a:schemeClr val="accent1"/>
+          </a:lnRef>
+          <a:fillRef idx="3">
+            <a:schemeClr val="accent1"/>
+          </a:fillRef>
+          <a:effectRef idx="2">
+            <a:schemeClr val="accent1"/>
+          </a:effectRef>
+          <a:fontRef idx="minor">
+            <a:schemeClr val="lt1"/>
+          </a:fontRef>
+        </p:style>
+        <p:txBody>
+          <a:bodyPr rtlCol="0" anchor="ctr"/>
+          <a:lstStyle/>
+          <a:p>
+            <a:pPr algn="ctr"/>
+          </a:p>
+        </p:txBody>
+      </p:sp>
+      <p:sp>
+        <p:nvSpPr>
+          <p:cNvPr id="21" name="TextBox 20"/>
+          <p:cNvSpPr txBox="1"/>
+          <p:nvPr/>
+        </p:nvSpPr>
+        <p:spPr>
+          <a:xfrm>
+            <a:off x="914400" y="5440680"/>
+            <a:ext cx="10698480" cy="365760"/>
+          </a:xfrm>
+          <a:prstGeom prst="rect">
+            <a:avLst/>
+          </a:prstGeom>
+          <a:noFill/>
+        </p:spPr>
+        <p:txBody>
+          <a:bodyPr wrap="square" lIns="45720" rIns="45720">
+            <a:spAutoFit/>
+          </a:bodyPr>
+          <a:lstStyle/>
+          <a:p>
+            <a:pPr algn="l"/>
+            <a:r>
+              <a:rPr sz="1500" b="1">
+                <a:solidFill>
+                  <a:srgbClr val="1E4B8F"/>
+                </a:solidFill>
+                <a:latin typeface="Calibri"/>
+              </a:rPr>
+              <a:t>Two-layer scope guardrails</a:t>
+            </a:r>
+          </a:p>
+        </p:txBody>
+      </p:sp>
+      <p:sp>
+        <p:nvSpPr>
+          <p:cNvPr id="22" name="TextBox 21"/>
+          <p:cNvSpPr txBox="1"/>
+          <p:nvPr/>
+        </p:nvSpPr>
+        <p:spPr>
+          <a:xfrm>
+            <a:off x="914400" y="5788152"/>
+            <a:ext cx="10698480" cy="502920"/>
+          </a:xfrm>
+          <a:prstGeom prst="rect">
+            <a:avLst/>
+          </a:prstGeom>
+          <a:noFill/>
+        </p:spPr>
+        <p:txBody>
+          <a:bodyPr wrap="square" lIns="45720" rIns="45720">
+            <a:spAutoFit/>
+          </a:bodyPr>
+          <a:lstStyle/>
+          <a:p>
+            <a:pPr algn="l"/>
+            <a:r>
+              <a:rPr sz="1200" b="0">
+                <a:solidFill>
+                  <a:srgbClr val="222222"/>
+                </a:solidFill>
+                <a:latin typeface="Calibri"/>
+              </a:rPr>
+              <a:t>Agent refuses off-topic questions (weather, news, etc.) without calling any tool. UI also suppresses charts on refusals so the visual never contradicts a 'cannot answer' response.</a:t>
             </a:r>
           </a:p>
         </p:txBody>

</xml_diff>